<commit_message>
E급 = Emperor 확정, 헌제 King 지정 금지
기획자 확인 사항을 GDD에 반영했다.

- E는 D 아래 등급이 아니라 Emperor의 약자다. 등급 서열 밖의 별도 분류이며
  헌제 한 명뿐이다. SP 7은 전 등급 최고(S급 6보다 비싸다).
  능력치 1/1/1은 "「황제옹립」 하나로만 존재 가치가 성립한다"는 의도된 설계.
- 헌제의 King 지정은 금지로 확정 (§12 미결 9번 해소).
- §3.6의 「차동풍」 설명을 B3 판정에 맞게 정정 — 2회 사용이 아니라
  이미 써버린 스킬의 재활성화다.
- 엑셀 갱신 반영: 식소사번 주기 time 100 → 200.

Co-Authored-By: Claude Opus 5 (1M context) <noreply@anthropic.com>
</commit_message>
<xml_diff>
--- a/docs/삼국 약식 체스.pptx
+++ b/docs/삼국 약식 체스.pptx
@@ -215,7 +215,7 @@
           <a:p>
             <a:fld id="{B4F07136-05B9-4084-83BF-56E9BCCDA6F9}" type="datetimeFigureOut">
               <a:rPr lang="ko-KR" altLang="en-US" smtClean="0"/>
-              <a:t>2026-07-25</a:t>
+              <a:t>2026-07-31</a:t>
             </a:fld>
             <a:endParaRPr lang="ko-KR" altLang="en-US"/>
           </a:p>
@@ -1253,7 +1253,7 @@
           <a:p>
             <a:fld id="{7612FBA5-57BE-4E0D-B9AB-8FA0886BAC02}" type="datetimeFigureOut">
               <a:rPr lang="ko-KR" altLang="en-US" smtClean="0"/>
-              <a:t>2026-07-25</a:t>
+              <a:t>2026-07-31</a:t>
             </a:fld>
             <a:endParaRPr lang="ko-KR" altLang="en-US"/>
           </a:p>
@@ -1451,7 +1451,7 @@
           <a:p>
             <a:fld id="{7612FBA5-57BE-4E0D-B9AB-8FA0886BAC02}" type="datetimeFigureOut">
               <a:rPr lang="ko-KR" altLang="en-US" smtClean="0"/>
-              <a:t>2026-07-25</a:t>
+              <a:t>2026-07-31</a:t>
             </a:fld>
             <a:endParaRPr lang="ko-KR" altLang="en-US"/>
           </a:p>
@@ -1659,7 +1659,7 @@
           <a:p>
             <a:fld id="{7612FBA5-57BE-4E0D-B9AB-8FA0886BAC02}" type="datetimeFigureOut">
               <a:rPr lang="ko-KR" altLang="en-US" smtClean="0"/>
-              <a:t>2026-07-25</a:t>
+              <a:t>2026-07-31</a:t>
             </a:fld>
             <a:endParaRPr lang="ko-KR" altLang="en-US"/>
           </a:p>
@@ -1857,7 +1857,7 @@
           <a:p>
             <a:fld id="{7612FBA5-57BE-4E0D-B9AB-8FA0886BAC02}" type="datetimeFigureOut">
               <a:rPr lang="ko-KR" altLang="en-US" smtClean="0"/>
-              <a:t>2026-07-25</a:t>
+              <a:t>2026-07-31</a:t>
             </a:fld>
             <a:endParaRPr lang="ko-KR" altLang="en-US"/>
           </a:p>
@@ -2132,7 +2132,7 @@
           <a:p>
             <a:fld id="{7612FBA5-57BE-4E0D-B9AB-8FA0886BAC02}" type="datetimeFigureOut">
               <a:rPr lang="ko-KR" altLang="en-US" smtClean="0"/>
-              <a:t>2026-07-25</a:t>
+              <a:t>2026-07-31</a:t>
             </a:fld>
             <a:endParaRPr lang="ko-KR" altLang="en-US"/>
           </a:p>
@@ -2397,7 +2397,7 @@
           <a:p>
             <a:fld id="{7612FBA5-57BE-4E0D-B9AB-8FA0886BAC02}" type="datetimeFigureOut">
               <a:rPr lang="ko-KR" altLang="en-US" smtClean="0"/>
-              <a:t>2026-07-25</a:t>
+              <a:t>2026-07-31</a:t>
             </a:fld>
             <a:endParaRPr lang="ko-KR" altLang="en-US"/>
           </a:p>
@@ -2809,7 +2809,7 @@
           <a:p>
             <a:fld id="{7612FBA5-57BE-4E0D-B9AB-8FA0886BAC02}" type="datetimeFigureOut">
               <a:rPr lang="ko-KR" altLang="en-US" smtClean="0"/>
-              <a:t>2026-07-25</a:t>
+              <a:t>2026-07-31</a:t>
             </a:fld>
             <a:endParaRPr lang="ko-KR" altLang="en-US"/>
           </a:p>
@@ -2950,7 +2950,7 @@
           <a:p>
             <a:fld id="{7612FBA5-57BE-4E0D-B9AB-8FA0886BAC02}" type="datetimeFigureOut">
               <a:rPr lang="ko-KR" altLang="en-US" smtClean="0"/>
-              <a:t>2026-07-25</a:t>
+              <a:t>2026-07-31</a:t>
             </a:fld>
             <a:endParaRPr lang="ko-KR" altLang="en-US"/>
           </a:p>
@@ -3063,7 +3063,7 @@
           <a:p>
             <a:fld id="{7612FBA5-57BE-4E0D-B9AB-8FA0886BAC02}" type="datetimeFigureOut">
               <a:rPr lang="ko-KR" altLang="en-US" smtClean="0"/>
-              <a:t>2026-07-25</a:t>
+              <a:t>2026-07-31</a:t>
             </a:fld>
             <a:endParaRPr lang="ko-KR" altLang="en-US"/>
           </a:p>
@@ -3374,7 +3374,7 @@
           <a:p>
             <a:fld id="{7612FBA5-57BE-4E0D-B9AB-8FA0886BAC02}" type="datetimeFigureOut">
               <a:rPr lang="ko-KR" altLang="en-US" smtClean="0"/>
-              <a:t>2026-07-25</a:t>
+              <a:t>2026-07-31</a:t>
             </a:fld>
             <a:endParaRPr lang="ko-KR" altLang="en-US"/>
           </a:p>
@@ -3662,7 +3662,7 @@
           <a:p>
             <a:fld id="{7612FBA5-57BE-4E0D-B9AB-8FA0886BAC02}" type="datetimeFigureOut">
               <a:rPr lang="ko-KR" altLang="en-US" smtClean="0"/>
-              <a:t>2026-07-25</a:t>
+              <a:t>2026-07-31</a:t>
             </a:fld>
             <a:endParaRPr lang="ko-KR" altLang="en-US"/>
           </a:p>
@@ -3903,7 +3903,7 @@
           <a:p>
             <a:fld id="{7612FBA5-57BE-4E0D-B9AB-8FA0886BAC02}" type="datetimeFigureOut">
               <a:rPr lang="ko-KR" altLang="en-US" smtClean="0"/>
-              <a:t>2026-07-25</a:t>
+              <a:t>2026-07-31</a:t>
             </a:fld>
             <a:endParaRPr lang="ko-KR" altLang="en-US"/>
           </a:p>
@@ -5407,7 +5407,7 @@
           <p:nvPr>
             <p:extLst>
               <p:ext uri="{D42A27DB-BD31-4B8C-83A1-F6EECF244321}">
-                <p14:modId xmlns:p14="http://schemas.microsoft.com/office/powerpoint/2010/main" val="889577301"/>
+                <p14:modId xmlns:p14="http://schemas.microsoft.com/office/powerpoint/2010/main" val="2015751262"/>
               </p:ext>
             </p:extLst>
           </p:nvPr>
@@ -5841,12 +5841,18 @@
                         <a:buNone/>
                       </a:pPr>
                       <a:r>
-                        <a:rPr lang="ko-KR" sz="1400" u="none" strike="noStrike">
+                        <a:rPr lang="en-US" altLang="ko-KR" sz="1400" u="none" strike="noStrike" dirty="0">
                           <a:effectLst/>
                         </a:rPr>
-                        <a:t>8방향 1칸</a:t>
+                        <a:t>4</a:t>
                       </a:r>
-                      <a:endParaRPr lang="ko-KR" sz="1400" b="0" i="0" u="none" strike="noStrike">
+                      <a:r>
+                        <a:rPr lang="ko-KR" sz="1400" u="none" strike="noStrike" dirty="0">
+                          <a:effectLst/>
+                        </a:rPr>
+                        <a:t>방향 1칸</a:t>
+                      </a:r>
+                      <a:endParaRPr lang="ko-KR" sz="1400" b="0" i="0" u="none" strike="noStrike" dirty="0">
                         <a:solidFill>
                           <a:srgbClr val="000000"/>
                         </a:solidFill>
@@ -11379,7 +11385,7 @@
         <p:spPr>
           <a:xfrm>
             <a:off x="1013638" y="1059959"/>
-            <a:ext cx="9480191" cy="4193777"/>
+            <a:ext cx="9480191" cy="4609275"/>
           </a:xfrm>
           <a:prstGeom prst="rect">
             <a:avLst/>
@@ -11571,6 +11577,45 @@
                 <a:sym typeface="Wingdings" panose="05000000000000000000" pitchFamily="2" charset="2"/>
               </a:rPr>
               <a:t>]) %</a:t>
+            </a:r>
+          </a:p>
+          <a:p>
+            <a:pPr marL="285750" indent="-285750">
+              <a:lnSpc>
+                <a:spcPct val="150000"/>
+              </a:lnSpc>
+              <a:buFont typeface="Arial" panose="020B0604020202020204" pitchFamily="34" charset="0"/>
+              <a:buChar char="•"/>
+            </a:pPr>
+            <a:r>
+              <a:rPr lang="ko-KR" altLang="en-US" dirty="0">
+                <a:sym typeface="Wingdings" panose="05000000000000000000" pitchFamily="2" charset="2"/>
+              </a:rPr>
+              <a:t>통솔력</a:t>
+            </a:r>
+            <a:r>
+              <a:rPr lang="en-US" altLang="ko-KR" dirty="0">
+                <a:sym typeface="Wingdings" panose="05000000000000000000" pitchFamily="2" charset="2"/>
+              </a:rPr>
+              <a:t>: Waiting time </a:t>
+            </a:r>
+            <a:r>
+              <a:rPr lang="ko-KR" altLang="en-US" dirty="0">
+                <a:sym typeface="Wingdings" panose="05000000000000000000" pitchFamily="2" charset="2"/>
+              </a:rPr>
+              <a:t>에 영향 </a:t>
+            </a:r>
+            <a:r>
+              <a:rPr lang="en-US" altLang="ko-KR" dirty="0">
+                <a:sym typeface="Wingdings" panose="05000000000000000000" pitchFamily="2" charset="2"/>
+              </a:rPr>
+              <a:t> Waiting time = 190 - </a:t>
+            </a:r>
+            <a:r>
+              <a:rPr lang="ko-KR" altLang="en-US" dirty="0">
+                <a:sym typeface="Wingdings" panose="05000000000000000000" pitchFamily="2" charset="2"/>
+              </a:rPr>
+              <a:t>통솔력</a:t>
             </a:r>
             <a:endParaRPr lang="en-US" altLang="ko-KR" dirty="0"/>
           </a:p>

</xml_diff>